<commit_message>
updated .pptx .docx v_last
</commit_message>
<xml_diff>
--- a/conference/resources/Conference_v_last.pptx
+++ b/conference/resources/Conference_v_last.pptx
@@ -227,7 +227,7 @@
           <a:p>
             <a:fld id="{3DE9BC87-07BA-0548-91E7-15A1E0ED04A0}" type="datetimeFigureOut">
               <a:rPr lang="ru-GB" smtClean="0"/>
-              <a:t>04/20/2026</a:t>
+              <a:t>04/21/2026</a:t>
             </a:fld>
             <a:endParaRPr lang="ru-GB"/>
           </a:p>
@@ -1460,7 +1460,7 @@
           <a:p>
             <a:fld id="{2970958D-8FD3-704D-8A72-D3764ABAF413}" type="datetimeFigureOut">
               <a:rPr lang="ru-GB" smtClean="0"/>
-              <a:t>04/20/2026</a:t>
+              <a:t>04/21/2026</a:t>
             </a:fld>
             <a:endParaRPr lang="ru-GB"/>
           </a:p>
@@ -1660,7 +1660,7 @@
           <a:p>
             <a:fld id="{2970958D-8FD3-704D-8A72-D3764ABAF413}" type="datetimeFigureOut">
               <a:rPr lang="ru-GB" smtClean="0"/>
-              <a:t>04/20/2026</a:t>
+              <a:t>04/21/2026</a:t>
             </a:fld>
             <a:endParaRPr lang="ru-GB"/>
           </a:p>
@@ -1870,7 +1870,7 @@
           <a:p>
             <a:fld id="{2970958D-8FD3-704D-8A72-D3764ABAF413}" type="datetimeFigureOut">
               <a:rPr lang="ru-GB" smtClean="0"/>
-              <a:t>04/20/2026</a:t>
+              <a:t>04/21/2026</a:t>
             </a:fld>
             <a:endParaRPr lang="ru-GB"/>
           </a:p>
@@ -2070,7 +2070,7 @@
           <a:p>
             <a:fld id="{2970958D-8FD3-704D-8A72-D3764ABAF413}" type="datetimeFigureOut">
               <a:rPr lang="ru-GB" smtClean="0"/>
-              <a:t>04/20/2026</a:t>
+              <a:t>04/21/2026</a:t>
             </a:fld>
             <a:endParaRPr lang="ru-GB"/>
           </a:p>
@@ -2346,7 +2346,7 @@
           <a:p>
             <a:fld id="{2970958D-8FD3-704D-8A72-D3764ABAF413}" type="datetimeFigureOut">
               <a:rPr lang="ru-GB" smtClean="0"/>
-              <a:t>04/20/2026</a:t>
+              <a:t>04/21/2026</a:t>
             </a:fld>
             <a:endParaRPr lang="ru-GB"/>
           </a:p>
@@ -2614,7 +2614,7 @@
           <a:p>
             <a:fld id="{2970958D-8FD3-704D-8A72-D3764ABAF413}" type="datetimeFigureOut">
               <a:rPr lang="ru-GB" smtClean="0"/>
-              <a:t>04/20/2026</a:t>
+              <a:t>04/21/2026</a:t>
             </a:fld>
             <a:endParaRPr lang="ru-GB"/>
           </a:p>
@@ -3029,7 +3029,7 @@
           <a:p>
             <a:fld id="{2970958D-8FD3-704D-8A72-D3764ABAF413}" type="datetimeFigureOut">
               <a:rPr lang="ru-GB" smtClean="0"/>
-              <a:t>04/20/2026</a:t>
+              <a:t>04/21/2026</a:t>
             </a:fld>
             <a:endParaRPr lang="ru-GB"/>
           </a:p>
@@ -3171,7 +3171,7 @@
           <a:p>
             <a:fld id="{2970958D-8FD3-704D-8A72-D3764ABAF413}" type="datetimeFigureOut">
               <a:rPr lang="ru-GB" smtClean="0"/>
-              <a:t>04/20/2026</a:t>
+              <a:t>04/21/2026</a:t>
             </a:fld>
             <a:endParaRPr lang="ru-GB"/>
           </a:p>
@@ -3284,7 +3284,7 @@
           <a:p>
             <a:fld id="{2970958D-8FD3-704D-8A72-D3764ABAF413}" type="datetimeFigureOut">
               <a:rPr lang="ru-GB" smtClean="0"/>
-              <a:t>04/20/2026</a:t>
+              <a:t>04/21/2026</a:t>
             </a:fld>
             <a:endParaRPr lang="ru-GB"/>
           </a:p>
@@ -3597,7 +3597,7 @@
           <a:p>
             <a:fld id="{2970958D-8FD3-704D-8A72-D3764ABAF413}" type="datetimeFigureOut">
               <a:rPr lang="ru-GB" smtClean="0"/>
-              <a:t>04/20/2026</a:t>
+              <a:t>04/21/2026</a:t>
             </a:fld>
             <a:endParaRPr lang="ru-GB"/>
           </a:p>
@@ -3886,7 +3886,7 @@
           <a:p>
             <a:fld id="{2970958D-8FD3-704D-8A72-D3764ABAF413}" type="datetimeFigureOut">
               <a:rPr lang="ru-GB" smtClean="0"/>
-              <a:t>04/20/2026</a:t>
+              <a:t>04/21/2026</a:t>
             </a:fld>
             <a:endParaRPr lang="ru-GB"/>
           </a:p>
@@ -4129,7 +4129,7 @@
           <a:p>
             <a:fld id="{2970958D-8FD3-704D-8A72-D3764ABAF413}" type="datetimeFigureOut">
               <a:rPr lang="ru-GB" smtClean="0"/>
-              <a:t>04/20/2026</a:t>
+              <a:t>04/21/2026</a:t>
             </a:fld>
             <a:endParaRPr lang="ru-GB"/>
           </a:p>
@@ -4560,8 +4560,8 @@
         </p:nvSpPr>
         <p:spPr>
           <a:xfrm>
-            <a:off x="1822764" y="1448553"/>
-            <a:ext cx="8851271" cy="1754326"/>
+            <a:off x="1143708" y="298296"/>
+            <a:ext cx="9904579" cy="1015663"/>
           </a:xfrm>
           <a:prstGeom prst="rect">
             <a:avLst/>
@@ -4574,51 +4574,37 @@
           </a:bodyPr>
           <a:lstStyle/>
           <a:p>
-            <a:r>
-              <a:rPr lang="ru-RU" sz="3600" dirty="0"/>
-              <a:t>Тема</a:t>
-            </a:r>
-            <a:r>
-              <a:rPr lang="en-US" sz="3600" dirty="0"/>
-              <a:t>:</a:t>
-            </a:r>
-          </a:p>
-          <a:p>
-            <a:pPr lvl="1"/>
-            <a:r>
-              <a:rPr lang="ru-RU" sz="3600" b="1" dirty="0" err="1"/>
-              <a:t>Мультимастер</a:t>
-            </a:r>
-            <a:r>
-              <a:rPr lang="ru-RU" sz="3600" b="1" dirty="0"/>
-              <a:t>-архитектура на основе </a:t>
-            </a:r>
-            <a:r>
-              <a:rPr lang="en-US" sz="3600" b="1" dirty="0"/>
-              <a:t>PostgreSQL, </a:t>
-            </a:r>
-            <a:r>
-              <a:rPr lang="en-US" sz="3600" b="1" dirty="0" err="1"/>
-              <a:t>Citus</a:t>
-            </a:r>
-            <a:r>
-              <a:rPr lang="ru-RU" sz="3600" b="1" dirty="0"/>
-              <a:t> и </a:t>
-            </a:r>
-            <a:r>
-              <a:rPr lang="en-US" sz="3600" b="1" dirty="0"/>
-              <a:t>Kubernetes</a:t>
-            </a:r>
-            <a:endParaRPr lang="ru-BY" sz="3600" b="1" dirty="0"/>
-          </a:p>
-        </p:txBody>
-      </p:sp>
-      <p:sp>
-        <p:nvSpPr>
-          <p:cNvPr id="3" name="TextBox 2">
-            <a:extLst>
-              <a:ext uri="{FF2B5EF4-FFF2-40B4-BE49-F238E27FC236}">
-                <a16:creationId xmlns:a16="http://schemas.microsoft.com/office/drawing/2014/main" id="{A802F8D0-F169-9736-A7EC-4BB8032D7931}"/>
+            <a:pPr algn="ctr"/>
+            <a:r>
+              <a:rPr lang="ru-RU" sz="2000" dirty="0">
+                <a:latin typeface="Times New Roman" panose="02020603050405020304" pitchFamily="18" charset="0"/>
+                <a:cs typeface="Times New Roman" panose="02020603050405020304" pitchFamily="18" charset="0"/>
+              </a:rPr>
+              <a:t>МИНИСТЕРСТВО ОБРАЗОВАНИЯ РЕСПУБЛИКИ БЕЛАРУСЬ</a:t>
+            </a:r>
+          </a:p>
+          <a:p>
+            <a:pPr algn="ctr"/>
+            <a:r>
+              <a:rPr lang="ru-RU" sz="2000" dirty="0">
+                <a:latin typeface="Times New Roman" panose="02020603050405020304" pitchFamily="18" charset="0"/>
+                <a:cs typeface="Times New Roman" panose="02020603050405020304" pitchFamily="18" charset="0"/>
+              </a:rPr>
+              <a:t>Учреждения образования «БЕЛОРУССКИЙ ГОСУДАСТВЕННЫЙ ТЕХНОЛОГИЧЕСКИЙ УНИВЕРСИТЕТ»</a:t>
+            </a:r>
+            <a:endParaRPr lang="ru-BY" sz="2000" dirty="0">
+              <a:latin typeface="Times New Roman" panose="02020603050405020304" pitchFamily="18" charset="0"/>
+              <a:cs typeface="Times New Roman" panose="02020603050405020304" pitchFamily="18" charset="0"/>
+            </a:endParaRPr>
+          </a:p>
+        </p:txBody>
+      </p:sp>
+      <p:sp>
+        <p:nvSpPr>
+          <p:cNvPr id="4" name="TextBox 3">
+            <a:extLst>
+              <a:ext uri="{FF2B5EF4-FFF2-40B4-BE49-F238E27FC236}">
+                <a16:creationId xmlns:a16="http://schemas.microsoft.com/office/drawing/2014/main" id="{3470C0DF-050C-2A52-C2A5-54CFA07D5D42}"/>
               </a:ext>
             </a:extLst>
           </p:cNvPr>
@@ -4627,8 +4613,8 @@
         </p:nvSpPr>
         <p:spPr>
           <a:xfrm>
-            <a:off x="7748258" y="4898203"/>
-            <a:ext cx="3867338" cy="1200329"/>
+            <a:off x="2897048" y="1721313"/>
+            <a:ext cx="6397900" cy="707886"/>
           </a:xfrm>
           <a:prstGeom prst="rect">
             <a:avLst/>
@@ -4641,61 +4627,313 @@
           </a:bodyPr>
           <a:lstStyle/>
           <a:p>
-            <a:r>
-              <a:rPr lang="en-US" sz="3600" i="1" dirty="0"/>
-              <a:t>c</a:t>
-            </a:r>
-            <a:r>
-              <a:rPr lang="ru-RU" sz="3600" i="1" dirty="0"/>
-              <a:t>т</a:t>
-            </a:r>
-            <a:r>
-              <a:rPr lang="en-US" sz="3600" i="1" dirty="0"/>
-              <a:t>. 2 </a:t>
-            </a:r>
-            <a:r>
-              <a:rPr lang="ru-RU" sz="3600" i="1" dirty="0"/>
-              <a:t>к</a:t>
-            </a:r>
-            <a:r>
-              <a:rPr lang="en-US" sz="3600" i="1" dirty="0"/>
-              <a:t>. 2 </a:t>
-            </a:r>
-            <a:r>
-              <a:rPr lang="ru-RU" sz="3600" i="1" dirty="0" err="1"/>
-              <a:t>гр</a:t>
-            </a:r>
-            <a:r>
-              <a:rPr lang="en-US" sz="3600" i="1" dirty="0"/>
-              <a:t>. </a:t>
-            </a:r>
-            <a:r>
-              <a:rPr lang="ru-RU" sz="3600" i="1" dirty="0"/>
-              <a:t>ФИТ</a:t>
-            </a:r>
-            <a:endParaRPr lang="en-US" sz="3600" i="1" dirty="0"/>
-          </a:p>
-          <a:p>
-            <a:r>
-              <a:rPr lang="ru-RU" sz="3600" i="1" dirty="0"/>
-              <a:t>Марушко Т</a:t>
-            </a:r>
-            <a:r>
-              <a:rPr lang="en-US" sz="3600" i="1" dirty="0"/>
-              <a:t>. </a:t>
-            </a:r>
-            <a:r>
-              <a:rPr lang="ru-RU" sz="3600" i="1" dirty="0"/>
-              <a:t>Ф</a:t>
-            </a:r>
-            <a:r>
-              <a:rPr lang="en-US" sz="3600" i="1" dirty="0"/>
-              <a:t>.</a:t>
-            </a:r>
-            <a:endParaRPr lang="ru-BY" sz="3600" i="1" dirty="0"/>
-          </a:p>
-        </p:txBody>
-      </p:sp>
+            <a:pPr algn="ctr"/>
+            <a:r>
+              <a:rPr lang="ru-RU" sz="2000" dirty="0">
+                <a:latin typeface="Times New Roman" panose="02020603050405020304" pitchFamily="18" charset="0"/>
+                <a:cs typeface="Times New Roman" panose="02020603050405020304" pitchFamily="18" charset="0"/>
+              </a:rPr>
+              <a:t>Факультет информационных технологий</a:t>
+            </a:r>
+          </a:p>
+          <a:p>
+            <a:pPr algn="ctr"/>
+            <a:r>
+              <a:rPr lang="ru-RU" sz="2000" dirty="0">
+                <a:latin typeface="Times New Roman" panose="02020603050405020304" pitchFamily="18" charset="0"/>
+                <a:cs typeface="Times New Roman" panose="02020603050405020304" pitchFamily="18" charset="0"/>
+              </a:rPr>
+              <a:t>Кафедра информационных систем и технологий</a:t>
+            </a:r>
+            <a:endParaRPr lang="ru-BY" sz="2000" dirty="0">
+              <a:latin typeface="Times New Roman" panose="02020603050405020304" pitchFamily="18" charset="0"/>
+              <a:cs typeface="Times New Roman" panose="02020603050405020304" pitchFamily="18" charset="0"/>
+            </a:endParaRPr>
+          </a:p>
+        </p:txBody>
+      </p:sp>
+      <p:sp>
+        <p:nvSpPr>
+          <p:cNvPr id="5" name="TextBox 4">
+            <a:extLst>
+              <a:ext uri="{FF2B5EF4-FFF2-40B4-BE49-F238E27FC236}">
+                <a16:creationId xmlns:a16="http://schemas.microsoft.com/office/drawing/2014/main" id="{3AF420EC-BF40-0F3F-D76A-E3B81861DD76}"/>
+              </a:ext>
+            </a:extLst>
+          </p:cNvPr>
+          <p:cNvSpPr txBox="1"/>
+          <p:nvPr/>
+        </p:nvSpPr>
+        <p:spPr>
+          <a:xfrm>
+            <a:off x="6567938" y="5044354"/>
+            <a:ext cx="5624062" cy="707886"/>
+          </a:xfrm>
+          <a:prstGeom prst="rect">
+            <a:avLst/>
+          </a:prstGeom>
+          <a:noFill/>
+        </p:spPr>
+        <p:txBody>
+          <a:bodyPr wrap="square" rtlCol="0">
+            <a:spAutoFit/>
+          </a:bodyPr>
+          <a:lstStyle/>
+          <a:p>
+            <a:r>
+              <a:rPr lang="ru-RU" sz="2000" dirty="0">
+                <a:latin typeface="Times New Roman" panose="02020603050405020304" pitchFamily="18" charset="0"/>
+                <a:cs typeface="Times New Roman" panose="02020603050405020304" pitchFamily="18" charset="0"/>
+              </a:rPr>
+              <a:t>Выполнил</a:t>
+            </a:r>
+            <a:r>
+              <a:rPr lang="en-US" sz="2000" dirty="0">
+                <a:latin typeface="Times New Roman" panose="02020603050405020304" pitchFamily="18" charset="0"/>
+                <a:cs typeface="Times New Roman" panose="02020603050405020304" pitchFamily="18" charset="0"/>
+              </a:rPr>
+              <a:t>: </a:t>
+            </a:r>
+            <a:r>
+              <a:rPr lang="ru-RU" sz="2000" dirty="0">
+                <a:latin typeface="Times New Roman" panose="02020603050405020304" pitchFamily="18" charset="0"/>
+                <a:cs typeface="Times New Roman" panose="02020603050405020304" pitchFamily="18" charset="0"/>
+              </a:rPr>
+              <a:t>Марушко Тимофей Фёдорович</a:t>
+            </a:r>
+          </a:p>
+          <a:p>
+            <a:r>
+              <a:rPr lang="ru-RU" sz="2000" dirty="0">
+                <a:latin typeface="Times New Roman" panose="02020603050405020304" pitchFamily="18" charset="0"/>
+                <a:cs typeface="Times New Roman" panose="02020603050405020304" pitchFamily="18" charset="0"/>
+              </a:rPr>
+              <a:t>Руководитель</a:t>
+            </a:r>
+            <a:r>
+              <a:rPr lang="en-US" sz="2000" dirty="0">
+                <a:latin typeface="Times New Roman" panose="02020603050405020304" pitchFamily="18" charset="0"/>
+                <a:cs typeface="Times New Roman" panose="02020603050405020304" pitchFamily="18" charset="0"/>
+              </a:rPr>
+              <a:t>: </a:t>
+            </a:r>
+            <a:r>
+              <a:rPr lang="ru-RU" sz="2000" dirty="0">
+                <a:latin typeface="Times New Roman" panose="02020603050405020304" pitchFamily="18" charset="0"/>
+                <a:cs typeface="Times New Roman" panose="02020603050405020304" pitchFamily="18" charset="0"/>
+              </a:rPr>
+              <a:t>Блинова Евгения Александровна</a:t>
+            </a:r>
+            <a:endParaRPr lang="ru-BY" sz="2000" dirty="0">
+              <a:latin typeface="Times New Roman" panose="02020603050405020304" pitchFamily="18" charset="0"/>
+              <a:cs typeface="Times New Roman" panose="02020603050405020304" pitchFamily="18" charset="0"/>
+            </a:endParaRPr>
+          </a:p>
+        </p:txBody>
+      </p:sp>
+      <p:sp>
+        <p:nvSpPr>
+          <p:cNvPr id="7" name="TextBox 6">
+            <a:extLst>
+              <a:ext uri="{FF2B5EF4-FFF2-40B4-BE49-F238E27FC236}">
+                <a16:creationId xmlns:a16="http://schemas.microsoft.com/office/drawing/2014/main" id="{FB2DB5B5-A655-5215-CF69-831A12D4C8BD}"/>
+              </a:ext>
+            </a:extLst>
+          </p:cNvPr>
+          <p:cNvSpPr txBox="1"/>
+          <p:nvPr/>
+        </p:nvSpPr>
+        <p:spPr>
+          <a:xfrm>
+            <a:off x="5215598" y="6159594"/>
+            <a:ext cx="1760797" cy="400110"/>
+          </a:xfrm>
+          <a:prstGeom prst="rect">
+            <a:avLst/>
+          </a:prstGeom>
+          <a:noFill/>
+        </p:spPr>
+        <p:txBody>
+          <a:bodyPr wrap="square" rtlCol="0">
+            <a:spAutoFit/>
+          </a:bodyPr>
+          <a:lstStyle/>
+          <a:p>
+            <a:pPr algn="ctr"/>
+            <a:r>
+              <a:rPr lang="ru-RU" sz="2000" dirty="0">
+                <a:latin typeface="Times New Roman" panose="02020603050405020304" pitchFamily="18" charset="0"/>
+                <a:cs typeface="Times New Roman" panose="02020603050405020304" pitchFamily="18" charset="0"/>
+              </a:rPr>
+              <a:t>Минск</a:t>
+            </a:r>
+            <a:r>
+              <a:rPr lang="en-US" sz="2000" dirty="0">
+                <a:latin typeface="Times New Roman" panose="02020603050405020304" pitchFamily="18" charset="0"/>
+                <a:cs typeface="Times New Roman" panose="02020603050405020304" pitchFamily="18" charset="0"/>
+              </a:rPr>
+              <a:t> 2026</a:t>
+            </a:r>
+            <a:endParaRPr lang="ru-BY" sz="2000" dirty="0">
+              <a:latin typeface="Times New Roman" panose="02020603050405020304" pitchFamily="18" charset="0"/>
+              <a:cs typeface="Times New Roman" panose="02020603050405020304" pitchFamily="18" charset="0"/>
+            </a:endParaRPr>
+          </a:p>
+        </p:txBody>
+      </p:sp>
+      <p:sp>
+        <p:nvSpPr>
+          <p:cNvPr id="8" name="TextBox 7">
+            <a:extLst>
+              <a:ext uri="{FF2B5EF4-FFF2-40B4-BE49-F238E27FC236}">
+                <a16:creationId xmlns:a16="http://schemas.microsoft.com/office/drawing/2014/main" id="{A00F1ECC-B2A1-7B57-C516-467089B35143}"/>
+              </a:ext>
+            </a:extLst>
+          </p:cNvPr>
+          <p:cNvSpPr txBox="1"/>
+          <p:nvPr/>
+        </p:nvSpPr>
+        <p:spPr>
+          <a:xfrm>
+            <a:off x="1445938" y="3075057"/>
+            <a:ext cx="9602349" cy="707886"/>
+          </a:xfrm>
+          <a:prstGeom prst="rect">
+            <a:avLst/>
+          </a:prstGeom>
+          <a:noFill/>
+        </p:spPr>
+        <p:txBody>
+          <a:bodyPr wrap="square" rtlCol="0">
+            <a:spAutoFit/>
+          </a:bodyPr>
+          <a:lstStyle/>
+          <a:p>
+            <a:pPr algn="ctr"/>
+            <a:r>
+              <a:rPr lang="ru-RU" sz="2000" b="1" dirty="0">
+                <a:latin typeface="Times New Roman" panose="02020603050405020304" pitchFamily="18" charset="0"/>
+                <a:cs typeface="Times New Roman" panose="02020603050405020304" pitchFamily="18" charset="0"/>
+              </a:rPr>
+              <a:t>Тема проекта</a:t>
+            </a:r>
+            <a:r>
+              <a:rPr lang="en-US" sz="2000" b="1" dirty="0">
+                <a:latin typeface="Times New Roman" panose="02020603050405020304" pitchFamily="18" charset="0"/>
+                <a:cs typeface="Times New Roman" panose="02020603050405020304" pitchFamily="18" charset="0"/>
+              </a:rPr>
+              <a:t>:</a:t>
+            </a:r>
+          </a:p>
+          <a:p>
+            <a:pPr algn="ctr"/>
+            <a:r>
+              <a:rPr lang="ru-RU" sz="2000" dirty="0">
+                <a:latin typeface="Times New Roman" panose="02020603050405020304" pitchFamily="18" charset="0"/>
+                <a:cs typeface="Times New Roman" panose="02020603050405020304" pitchFamily="18" charset="0"/>
+              </a:rPr>
+              <a:t>«</a:t>
+            </a:r>
+            <a:r>
+              <a:rPr lang="ru-RU" sz="2000" dirty="0" err="1">
+                <a:latin typeface="Times New Roman" panose="02020603050405020304" pitchFamily="18" charset="0"/>
+                <a:cs typeface="Times New Roman" panose="02020603050405020304" pitchFamily="18" charset="0"/>
+              </a:rPr>
+              <a:t>Мультимастер</a:t>
+            </a:r>
+            <a:r>
+              <a:rPr lang="ru-RU" sz="2000" dirty="0">
+                <a:latin typeface="Times New Roman" panose="02020603050405020304" pitchFamily="18" charset="0"/>
+                <a:cs typeface="Times New Roman" panose="02020603050405020304" pitchFamily="18" charset="0"/>
+              </a:rPr>
+              <a:t> архитектура на основе технологий </a:t>
+            </a:r>
+            <a:r>
+              <a:rPr lang="en-US" sz="2000" dirty="0" err="1">
+                <a:latin typeface="Times New Roman" panose="02020603050405020304" pitchFamily="18" charset="0"/>
+                <a:cs typeface="Times New Roman" panose="02020603050405020304" pitchFamily="18" charset="0"/>
+              </a:rPr>
+              <a:t>PostgesSQL</a:t>
+            </a:r>
+            <a:r>
+              <a:rPr lang="en-US" sz="2000" dirty="0">
+                <a:latin typeface="Times New Roman" panose="02020603050405020304" pitchFamily="18" charset="0"/>
+                <a:cs typeface="Times New Roman" panose="02020603050405020304" pitchFamily="18" charset="0"/>
+              </a:rPr>
+              <a:t>, </a:t>
+            </a:r>
+            <a:r>
+              <a:rPr lang="en-US" sz="2000" dirty="0" err="1">
+                <a:latin typeface="Times New Roman" panose="02020603050405020304" pitchFamily="18" charset="0"/>
+                <a:cs typeface="Times New Roman" panose="02020603050405020304" pitchFamily="18" charset="0"/>
+              </a:rPr>
+              <a:t>Citus</a:t>
+            </a:r>
+            <a:r>
+              <a:rPr lang="en-US" sz="2000" dirty="0">
+                <a:latin typeface="Times New Roman" panose="02020603050405020304" pitchFamily="18" charset="0"/>
+                <a:cs typeface="Times New Roman" panose="02020603050405020304" pitchFamily="18" charset="0"/>
+              </a:rPr>
+              <a:t> </a:t>
+            </a:r>
+            <a:r>
+              <a:rPr lang="ru-RU" sz="2000" dirty="0">
+                <a:latin typeface="Times New Roman" panose="02020603050405020304" pitchFamily="18" charset="0"/>
+                <a:cs typeface="Times New Roman" panose="02020603050405020304" pitchFamily="18" charset="0"/>
+              </a:rPr>
+              <a:t>и </a:t>
+            </a:r>
+            <a:r>
+              <a:rPr lang="en-US" sz="2000" dirty="0">
+                <a:latin typeface="Times New Roman" panose="02020603050405020304" pitchFamily="18" charset="0"/>
+                <a:cs typeface="Times New Roman" panose="02020603050405020304" pitchFamily="18" charset="0"/>
+              </a:rPr>
+              <a:t>Kubernetes</a:t>
+            </a:r>
+            <a:r>
+              <a:rPr lang="ru-RU" sz="2000" dirty="0">
+                <a:latin typeface="Times New Roman" panose="02020603050405020304" pitchFamily="18" charset="0"/>
+                <a:cs typeface="Times New Roman" panose="02020603050405020304" pitchFamily="18" charset="0"/>
+              </a:rPr>
+              <a:t>»</a:t>
+            </a:r>
+            <a:endParaRPr lang="ru-BY" sz="2000" dirty="0">
+              <a:latin typeface="Times New Roman" panose="02020603050405020304" pitchFamily="18" charset="0"/>
+              <a:cs typeface="Times New Roman" panose="02020603050405020304" pitchFamily="18" charset="0"/>
+            </a:endParaRPr>
+          </a:p>
+        </p:txBody>
+      </p:sp>
+      <p:pic>
+        <p:nvPicPr>
+          <p:cNvPr id="10" name="Рисунок 9" descr="Изображение выглядит как зарисовка, графическая вставка, Графика, рисунок&#10;&#10;Контент, сгенерированный ИИ, может содержать ошибки.">
+            <a:extLst>
+              <a:ext uri="{FF2B5EF4-FFF2-40B4-BE49-F238E27FC236}">
+                <a16:creationId xmlns:a16="http://schemas.microsoft.com/office/drawing/2014/main" id="{AC7DD1C2-DE18-4EB7-95FD-7A652BA078EF}"/>
+              </a:ext>
+            </a:extLst>
+          </p:cNvPr>
+          <p:cNvPicPr>
+            <a:picLocks noChangeAspect="1"/>
+          </p:cNvPicPr>
+          <p:nvPr/>
+        </p:nvPicPr>
+        <p:blipFill>
+          <a:blip r:embed="rId3"/>
+          <a:stretch>
+            <a:fillRect/>
+          </a:stretch>
+        </p:blipFill>
+        <p:spPr>
+          <a:xfrm>
+            <a:off x="11048287" y="5971239"/>
+            <a:ext cx="702514" cy="776819"/>
+          </a:xfrm>
+          <a:prstGeom prst="rect">
+            <a:avLst/>
+          </a:prstGeom>
+        </p:spPr>
+      </p:pic>
     </p:spTree>
     <p:extLst>
       <p:ext uri="{BB962C8B-B14F-4D97-AF65-F5344CB8AC3E}">
@@ -45263,7 +45501,7 @@
         </p:nvSpPr>
         <p:spPr>
           <a:xfrm>
-            <a:off x="613372" y="2173327"/>
+            <a:off x="1314057" y="1498624"/>
             <a:ext cx="4963563" cy="646331"/>
           </a:xfrm>
           <a:prstGeom prst="rect">
@@ -45278,10 +45516,16 @@
           <a:lstStyle/>
           <a:p>
             <a:r>
-              <a:rPr lang="ru-RU" sz="3600" b="1" i="1" dirty="0"/>
+              <a:rPr lang="ru-RU" sz="3600" b="1" i="1" dirty="0">
+                <a:latin typeface="Times New Roman" panose="02020603050405020304" pitchFamily="18" charset="0"/>
+                <a:cs typeface="Times New Roman" panose="02020603050405020304" pitchFamily="18" charset="0"/>
+              </a:rPr>
               <a:t>Спасибо за внимание</a:t>
             </a:r>
-            <a:endParaRPr lang="ru-BY" sz="3600" b="1" i="1" dirty="0"/>
+            <a:endParaRPr lang="ru-BY" sz="3600" b="1" i="1" dirty="0">
+              <a:latin typeface="Times New Roman" panose="02020603050405020304" pitchFamily="18" charset="0"/>
+              <a:cs typeface="Times New Roman" panose="02020603050405020304" pitchFamily="18" charset="0"/>
+            </a:endParaRPr>
           </a:p>
         </p:txBody>
       </p:sp>
@@ -45299,7 +45543,7 @@
         </p:nvSpPr>
         <p:spPr>
           <a:xfrm>
-            <a:off x="541699" y="5233181"/>
+            <a:off x="1314057" y="4593989"/>
             <a:ext cx="3867338" cy="1200329"/>
           </a:xfrm>
           <a:prstGeom prst="rect">
@@ -45314,57 +45558,99 @@
           <a:lstStyle/>
           <a:p>
             <a:r>
-              <a:rPr lang="en-US" sz="3600" i="1" dirty="0"/>
+              <a:rPr lang="en-US" sz="3600" i="1" dirty="0">
+                <a:latin typeface="Times New Roman" panose="02020603050405020304" pitchFamily="18" charset="0"/>
+                <a:cs typeface="Times New Roman" panose="02020603050405020304" pitchFamily="18" charset="0"/>
+              </a:rPr>
               <a:t>c</a:t>
             </a:r>
             <a:r>
-              <a:rPr lang="ru-RU" sz="3600" i="1" dirty="0"/>
+              <a:rPr lang="ru-RU" sz="3600" i="1" dirty="0">
+                <a:latin typeface="Times New Roman" panose="02020603050405020304" pitchFamily="18" charset="0"/>
+                <a:cs typeface="Times New Roman" panose="02020603050405020304" pitchFamily="18" charset="0"/>
+              </a:rPr>
               <a:t>т</a:t>
             </a:r>
             <a:r>
-              <a:rPr lang="en-US" sz="3600" i="1" dirty="0"/>
+              <a:rPr lang="en-US" sz="3600" i="1" dirty="0">
+                <a:latin typeface="Times New Roman" panose="02020603050405020304" pitchFamily="18" charset="0"/>
+                <a:cs typeface="Times New Roman" panose="02020603050405020304" pitchFamily="18" charset="0"/>
+              </a:rPr>
               <a:t>. 2 </a:t>
             </a:r>
             <a:r>
-              <a:rPr lang="ru-RU" sz="3600" i="1" dirty="0"/>
+              <a:rPr lang="ru-RU" sz="3600" i="1" dirty="0">
+                <a:latin typeface="Times New Roman" panose="02020603050405020304" pitchFamily="18" charset="0"/>
+                <a:cs typeface="Times New Roman" panose="02020603050405020304" pitchFamily="18" charset="0"/>
+              </a:rPr>
               <a:t>к</a:t>
             </a:r>
             <a:r>
-              <a:rPr lang="en-US" sz="3600" i="1" dirty="0"/>
+              <a:rPr lang="en-US" sz="3600" i="1" dirty="0">
+                <a:latin typeface="Times New Roman" panose="02020603050405020304" pitchFamily="18" charset="0"/>
+                <a:cs typeface="Times New Roman" panose="02020603050405020304" pitchFamily="18" charset="0"/>
+              </a:rPr>
               <a:t>. 2 </a:t>
             </a:r>
             <a:r>
-              <a:rPr lang="ru-RU" sz="3600" i="1" dirty="0" err="1"/>
+              <a:rPr lang="ru-RU" sz="3600" i="1" dirty="0" err="1">
+                <a:latin typeface="Times New Roman" panose="02020603050405020304" pitchFamily="18" charset="0"/>
+                <a:cs typeface="Times New Roman" panose="02020603050405020304" pitchFamily="18" charset="0"/>
+              </a:rPr>
               <a:t>гр</a:t>
             </a:r>
             <a:r>
-              <a:rPr lang="en-US" sz="3600" i="1" dirty="0"/>
+              <a:rPr lang="en-US" sz="3600" i="1" dirty="0">
+                <a:latin typeface="Times New Roman" panose="02020603050405020304" pitchFamily="18" charset="0"/>
+                <a:cs typeface="Times New Roman" panose="02020603050405020304" pitchFamily="18" charset="0"/>
+              </a:rPr>
               <a:t>. </a:t>
             </a:r>
             <a:r>
-              <a:rPr lang="ru-RU" sz="3600" i="1" dirty="0"/>
+              <a:rPr lang="ru-RU" sz="3600" i="1" dirty="0">
+                <a:latin typeface="Times New Roman" panose="02020603050405020304" pitchFamily="18" charset="0"/>
+                <a:cs typeface="Times New Roman" panose="02020603050405020304" pitchFamily="18" charset="0"/>
+              </a:rPr>
               <a:t>ФИТ</a:t>
             </a:r>
-            <a:endParaRPr lang="en-US" sz="3600" i="1" dirty="0"/>
-          </a:p>
-          <a:p>
-            <a:r>
-              <a:rPr lang="ru-RU" sz="3600" i="1" dirty="0"/>
+            <a:endParaRPr lang="en-US" sz="3600" i="1" dirty="0">
+              <a:latin typeface="Times New Roman" panose="02020603050405020304" pitchFamily="18" charset="0"/>
+              <a:cs typeface="Times New Roman" panose="02020603050405020304" pitchFamily="18" charset="0"/>
+            </a:endParaRPr>
+          </a:p>
+          <a:p>
+            <a:r>
+              <a:rPr lang="ru-RU" sz="3600" i="1" dirty="0">
+                <a:latin typeface="Times New Roman" panose="02020603050405020304" pitchFamily="18" charset="0"/>
+                <a:cs typeface="Times New Roman" panose="02020603050405020304" pitchFamily="18" charset="0"/>
+              </a:rPr>
               <a:t>Марушко Т</a:t>
             </a:r>
             <a:r>
-              <a:rPr lang="en-US" sz="3600" i="1" dirty="0"/>
+              <a:rPr lang="en-US" sz="3600" i="1" dirty="0">
+                <a:latin typeface="Times New Roman" panose="02020603050405020304" pitchFamily="18" charset="0"/>
+                <a:cs typeface="Times New Roman" panose="02020603050405020304" pitchFamily="18" charset="0"/>
+              </a:rPr>
               <a:t>. </a:t>
             </a:r>
             <a:r>
-              <a:rPr lang="ru-RU" sz="3600" i="1" dirty="0"/>
+              <a:rPr lang="ru-RU" sz="3600" i="1" dirty="0">
+                <a:latin typeface="Times New Roman" panose="02020603050405020304" pitchFamily="18" charset="0"/>
+                <a:cs typeface="Times New Roman" panose="02020603050405020304" pitchFamily="18" charset="0"/>
+              </a:rPr>
               <a:t>Ф</a:t>
             </a:r>
             <a:r>
-              <a:rPr lang="en-US" sz="3600" i="1" dirty="0"/>
+              <a:rPr lang="en-US" sz="3600" i="1" dirty="0">
+                <a:latin typeface="Times New Roman" panose="02020603050405020304" pitchFamily="18" charset="0"/>
+                <a:cs typeface="Times New Roman" panose="02020603050405020304" pitchFamily="18" charset="0"/>
+              </a:rPr>
               <a:t>.</a:t>
             </a:r>
-            <a:endParaRPr lang="ru-BY" sz="3600" i="1" dirty="0"/>
+            <a:endParaRPr lang="ru-BY" sz="3600" i="1" dirty="0">
+              <a:latin typeface="Times New Roman" panose="02020603050405020304" pitchFamily="18" charset="0"/>
+              <a:cs typeface="Times New Roman" panose="02020603050405020304" pitchFamily="18" charset="0"/>
+            </a:endParaRPr>
           </a:p>
         </p:txBody>
       </p:sp>

</xml_diff>

<commit_message>
completed conference; fixed .pptx & .docx
</commit_message>
<xml_diff>
--- a/conference/resources/Conference_v_last.pptx
+++ b/conference/resources/Conference_v_last.pptx
@@ -5,7 +5,7 @@
     <p:sldMasterId id="2147483648" r:id="rId1"/>
   </p:sldMasterIdLst>
   <p:notesMasterIdLst>
-    <p:notesMasterId r:id="rId33"/>
+    <p:notesMasterId r:id="rId36"/>
   </p:notesMasterIdLst>
   <p:sldIdLst>
     <p:sldId id="256" r:id="rId2"/>
@@ -38,7 +38,10 @@
     <p:sldId id="342" r:id="rId29"/>
     <p:sldId id="343" r:id="rId30"/>
     <p:sldId id="344" r:id="rId31"/>
-    <p:sldId id="346" r:id="rId32"/>
+    <p:sldId id="348" r:id="rId32"/>
+    <p:sldId id="346" r:id="rId33"/>
+    <p:sldId id="349" r:id="rId34"/>
+    <p:sldId id="347" r:id="rId35"/>
   </p:sldIdLst>
   <p:sldSz cx="12192000" cy="6858000"/>
   <p:notesSz cx="6858000" cy="9144000"/>
@@ -579,6 +582,258 @@
 </p:notes>
 </file>
 
+<file path=ppt/notesSlides/notesSlide10.xml><?xml version="1.0" encoding="utf-8"?>
+<p:notes xmlns:a="http://schemas.openxmlformats.org/drawingml/2006/main" xmlns:r="http://schemas.openxmlformats.org/officeDocument/2006/relationships" xmlns:p="http://schemas.openxmlformats.org/presentationml/2006/main">
+  <p:cSld>
+    <p:spTree>
+      <p:nvGrpSpPr>
+        <p:cNvPr id="1" name=""/>
+        <p:cNvGrpSpPr/>
+        <p:nvPr/>
+      </p:nvGrpSpPr>
+      <p:grpSpPr>
+        <a:xfrm>
+          <a:off x="0" y="0"/>
+          <a:ext cx="0" cy="0"/>
+          <a:chOff x="0" y="0"/>
+          <a:chExt cx="0" cy="0"/>
+        </a:xfrm>
+      </p:grpSpPr>
+      <p:sp>
+        <p:nvSpPr>
+          <p:cNvPr id="2" name="Образ слайда 1"/>
+          <p:cNvSpPr>
+            <a:spLocks noGrp="1" noRot="1" noChangeAspect="1"/>
+          </p:cNvSpPr>
+          <p:nvPr>
+            <p:ph type="sldImg"/>
+          </p:nvPr>
+        </p:nvSpPr>
+        <p:spPr/>
+      </p:sp>
+      <p:sp>
+        <p:nvSpPr>
+          <p:cNvPr id="3" name="Заметки 2"/>
+          <p:cNvSpPr>
+            <a:spLocks noGrp="1"/>
+          </p:cNvSpPr>
+          <p:nvPr>
+            <p:ph type="body" idx="1"/>
+          </p:nvPr>
+        </p:nvSpPr>
+        <p:spPr/>
+        <p:txBody>
+          <a:bodyPr/>
+          <a:lstStyle/>
+          <a:p>
+            <a:endParaRPr lang="ru-BY" dirty="0"/>
+          </a:p>
+        </p:txBody>
+      </p:sp>
+      <p:sp>
+        <p:nvSpPr>
+          <p:cNvPr id="4" name="Номер слайда 3"/>
+          <p:cNvSpPr>
+            <a:spLocks noGrp="1"/>
+          </p:cNvSpPr>
+          <p:nvPr>
+            <p:ph type="sldNum" sz="quarter" idx="5"/>
+          </p:nvPr>
+        </p:nvSpPr>
+        <p:spPr/>
+        <p:txBody>
+          <a:bodyPr/>
+          <a:lstStyle/>
+          <a:p>
+            <a:fld id="{03F863CD-2B76-284A-83FD-A2A4926A2F63}" type="slidenum">
+              <a:rPr lang="ru-GB" smtClean="0"/>
+              <a:t>32</a:t>
+            </a:fld>
+            <a:endParaRPr lang="ru-GB"/>
+          </a:p>
+        </p:txBody>
+      </p:sp>
+    </p:spTree>
+    <p:extLst>
+      <p:ext uri="{BB962C8B-B14F-4D97-AF65-F5344CB8AC3E}">
+        <p14:creationId xmlns:p14="http://schemas.microsoft.com/office/powerpoint/2010/main" val="1841236301"/>
+      </p:ext>
+    </p:extLst>
+  </p:cSld>
+  <p:clrMapOvr>
+    <a:masterClrMapping/>
+  </p:clrMapOvr>
+</p:notes>
+</file>
+
+<file path=ppt/notesSlides/notesSlide11.xml><?xml version="1.0" encoding="utf-8"?>
+<p:notes xmlns:a="http://schemas.openxmlformats.org/drawingml/2006/main" xmlns:r="http://schemas.openxmlformats.org/officeDocument/2006/relationships" xmlns:p="http://schemas.openxmlformats.org/presentationml/2006/main">
+  <p:cSld>
+    <p:spTree>
+      <p:nvGrpSpPr>
+        <p:cNvPr id="1" name=""/>
+        <p:cNvGrpSpPr/>
+        <p:nvPr/>
+      </p:nvGrpSpPr>
+      <p:grpSpPr>
+        <a:xfrm>
+          <a:off x="0" y="0"/>
+          <a:ext cx="0" cy="0"/>
+          <a:chOff x="0" y="0"/>
+          <a:chExt cx="0" cy="0"/>
+        </a:xfrm>
+      </p:grpSpPr>
+      <p:sp>
+        <p:nvSpPr>
+          <p:cNvPr id="2" name="Образ слайда 1"/>
+          <p:cNvSpPr>
+            <a:spLocks noGrp="1" noRot="1" noChangeAspect="1"/>
+          </p:cNvSpPr>
+          <p:nvPr>
+            <p:ph type="sldImg"/>
+          </p:nvPr>
+        </p:nvSpPr>
+        <p:spPr/>
+      </p:sp>
+      <p:sp>
+        <p:nvSpPr>
+          <p:cNvPr id="3" name="Заметки 2"/>
+          <p:cNvSpPr>
+            <a:spLocks noGrp="1"/>
+          </p:cNvSpPr>
+          <p:nvPr>
+            <p:ph type="body" idx="1"/>
+          </p:nvPr>
+        </p:nvSpPr>
+        <p:spPr/>
+        <p:txBody>
+          <a:bodyPr/>
+          <a:lstStyle/>
+          <a:p>
+            <a:endParaRPr lang="ru-BY" dirty="0"/>
+          </a:p>
+        </p:txBody>
+      </p:sp>
+      <p:sp>
+        <p:nvSpPr>
+          <p:cNvPr id="4" name="Номер слайда 3"/>
+          <p:cNvSpPr>
+            <a:spLocks noGrp="1"/>
+          </p:cNvSpPr>
+          <p:nvPr>
+            <p:ph type="sldNum" sz="quarter" idx="5"/>
+          </p:nvPr>
+        </p:nvSpPr>
+        <p:spPr/>
+        <p:txBody>
+          <a:bodyPr/>
+          <a:lstStyle/>
+          <a:p>
+            <a:fld id="{03F863CD-2B76-284A-83FD-A2A4926A2F63}" type="slidenum">
+              <a:rPr lang="ru-GB" smtClean="0"/>
+              <a:t>33</a:t>
+            </a:fld>
+            <a:endParaRPr lang="ru-GB"/>
+          </a:p>
+        </p:txBody>
+      </p:sp>
+    </p:spTree>
+    <p:extLst>
+      <p:ext uri="{BB962C8B-B14F-4D97-AF65-F5344CB8AC3E}">
+        <p14:creationId xmlns:p14="http://schemas.microsoft.com/office/powerpoint/2010/main" val="1823784273"/>
+      </p:ext>
+    </p:extLst>
+  </p:cSld>
+  <p:clrMapOvr>
+    <a:masterClrMapping/>
+  </p:clrMapOvr>
+</p:notes>
+</file>
+
+<file path=ppt/notesSlides/notesSlide12.xml><?xml version="1.0" encoding="utf-8"?>
+<p:notes xmlns:a="http://schemas.openxmlformats.org/drawingml/2006/main" xmlns:r="http://schemas.openxmlformats.org/officeDocument/2006/relationships" xmlns:p="http://schemas.openxmlformats.org/presentationml/2006/main">
+  <p:cSld>
+    <p:spTree>
+      <p:nvGrpSpPr>
+        <p:cNvPr id="1" name=""/>
+        <p:cNvGrpSpPr/>
+        <p:nvPr/>
+      </p:nvGrpSpPr>
+      <p:grpSpPr>
+        <a:xfrm>
+          <a:off x="0" y="0"/>
+          <a:ext cx="0" cy="0"/>
+          <a:chOff x="0" y="0"/>
+          <a:chExt cx="0" cy="0"/>
+        </a:xfrm>
+      </p:grpSpPr>
+      <p:sp>
+        <p:nvSpPr>
+          <p:cNvPr id="2" name="Образ слайда 1"/>
+          <p:cNvSpPr>
+            <a:spLocks noGrp="1" noRot="1" noChangeAspect="1"/>
+          </p:cNvSpPr>
+          <p:nvPr>
+            <p:ph type="sldImg"/>
+          </p:nvPr>
+        </p:nvSpPr>
+        <p:spPr/>
+      </p:sp>
+      <p:sp>
+        <p:nvSpPr>
+          <p:cNvPr id="3" name="Заметки 2"/>
+          <p:cNvSpPr>
+            <a:spLocks noGrp="1"/>
+          </p:cNvSpPr>
+          <p:nvPr>
+            <p:ph type="body" idx="1"/>
+          </p:nvPr>
+        </p:nvSpPr>
+        <p:spPr/>
+        <p:txBody>
+          <a:bodyPr/>
+          <a:lstStyle/>
+          <a:p>
+            <a:endParaRPr lang="ru-BY" dirty="0"/>
+          </a:p>
+        </p:txBody>
+      </p:sp>
+      <p:sp>
+        <p:nvSpPr>
+          <p:cNvPr id="4" name="Номер слайда 3"/>
+          <p:cNvSpPr>
+            <a:spLocks noGrp="1"/>
+          </p:cNvSpPr>
+          <p:nvPr>
+            <p:ph type="sldNum" sz="quarter" idx="5"/>
+          </p:nvPr>
+        </p:nvSpPr>
+        <p:spPr/>
+        <p:txBody>
+          <a:bodyPr/>
+          <a:lstStyle/>
+          <a:p>
+            <a:fld id="{03F863CD-2B76-284A-83FD-A2A4926A2F63}" type="slidenum">
+              <a:rPr lang="ru-GB" smtClean="0"/>
+              <a:t>34</a:t>
+            </a:fld>
+            <a:endParaRPr lang="ru-GB"/>
+          </a:p>
+        </p:txBody>
+      </p:sp>
+    </p:spTree>
+    <p:extLst>
+      <p:ext uri="{BB962C8B-B14F-4D97-AF65-F5344CB8AC3E}">
+        <p14:creationId xmlns:p14="http://schemas.microsoft.com/office/powerpoint/2010/main" val="2584894050"/>
+      </p:ext>
+    </p:extLst>
+  </p:cSld>
+  <p:clrMapOvr>
+    <a:masterClrMapping/>
+  </p:clrMapOvr>
+</p:notes>
+</file>
+
 <file path=ppt/notesSlides/notesSlide2.xml><?xml version="1.0" encoding="utf-8"?>
 <p:notes xmlns:a="http://schemas.openxmlformats.org/drawingml/2006/main" xmlns:r="http://schemas.openxmlformats.org/officeDocument/2006/relationships" xmlns:p="http://schemas.openxmlformats.org/presentationml/2006/main">
   <p:cSld>
@@ -1301,7 +1556,7 @@
     </p:spTree>
     <p:extLst>
       <p:ext uri="{BB962C8B-B14F-4D97-AF65-F5344CB8AC3E}">
-        <p14:creationId xmlns:p14="http://schemas.microsoft.com/office/powerpoint/2010/main" val="1841236301"/>
+        <p14:creationId xmlns:p14="http://schemas.microsoft.com/office/powerpoint/2010/main" val="3856586084"/>
       </p:ext>
     </p:extLst>
   </p:cSld>
@@ -45487,6 +45742,276 @@
           <a:chExt cx="0" cy="0"/>
         </a:xfrm>
       </p:grpSpPr>
+      <p:pic>
+        <p:nvPicPr>
+          <p:cNvPr id="5" name="Рисунок 4" descr="Изображение выглядит как текст, снимок экрана">
+            <a:extLst>
+              <a:ext uri="{FF2B5EF4-FFF2-40B4-BE49-F238E27FC236}">
+                <a16:creationId xmlns:a16="http://schemas.microsoft.com/office/drawing/2014/main" id="{8BE9B215-8E25-1945-317D-63A116F99E84}"/>
+              </a:ext>
+            </a:extLst>
+          </p:cNvPr>
+          <p:cNvPicPr>
+            <a:picLocks noChangeAspect="1"/>
+          </p:cNvPicPr>
+          <p:nvPr/>
+        </p:nvPicPr>
+        <p:blipFill>
+          <a:blip r:embed="rId3"/>
+          <a:stretch>
+            <a:fillRect/>
+          </a:stretch>
+        </p:blipFill>
+        <p:spPr>
+          <a:xfrm>
+            <a:off x="869949" y="165100"/>
+            <a:ext cx="10452101" cy="6527800"/>
+          </a:xfrm>
+          <a:prstGeom prst="rect">
+            <a:avLst/>
+          </a:prstGeom>
+        </p:spPr>
+      </p:pic>
+    </p:spTree>
+    <p:extLst>
+      <p:ext uri="{BB962C8B-B14F-4D97-AF65-F5344CB8AC3E}">
+        <p14:creationId xmlns:p14="http://schemas.microsoft.com/office/powerpoint/2010/main" val="50817050"/>
+      </p:ext>
+    </p:extLst>
+  </p:cSld>
+  <p:clrMapOvr>
+    <a:masterClrMapping/>
+  </p:clrMapOvr>
+</p:sld>
+</file>
+
+<file path=ppt/slides/slide32.xml><?xml version="1.0" encoding="utf-8"?>
+<p:sld xmlns:a="http://schemas.openxmlformats.org/drawingml/2006/main" xmlns:r="http://schemas.openxmlformats.org/officeDocument/2006/relationships" xmlns:p="http://schemas.openxmlformats.org/presentationml/2006/main">
+  <p:cSld>
+    <p:spTree>
+      <p:nvGrpSpPr>
+        <p:cNvPr id="1" name=""/>
+        <p:cNvGrpSpPr/>
+        <p:nvPr/>
+      </p:nvGrpSpPr>
+      <p:grpSpPr>
+        <a:xfrm>
+          <a:off x="0" y="0"/>
+          <a:ext cx="0" cy="0"/>
+          <a:chOff x="0" y="0"/>
+          <a:chExt cx="0" cy="0"/>
+        </a:xfrm>
+      </p:grpSpPr>
+      <p:pic>
+        <p:nvPicPr>
+          <p:cNvPr id="3" name="Рисунок 2" descr="Изображение выглядит как текст, снимок экрана&#10;&#10;Контент, сгенерированный ИИ, может содержать ошибки.">
+            <a:extLst>
+              <a:ext uri="{FF2B5EF4-FFF2-40B4-BE49-F238E27FC236}">
+                <a16:creationId xmlns:a16="http://schemas.microsoft.com/office/drawing/2014/main" id="{40E98EF0-93F0-EA71-73A6-2A8CC9EC4164}"/>
+              </a:ext>
+            </a:extLst>
+          </p:cNvPr>
+          <p:cNvPicPr>
+            <a:picLocks noChangeAspect="1"/>
+          </p:cNvPicPr>
+          <p:nvPr/>
+        </p:nvPicPr>
+        <p:blipFill>
+          <a:blip r:embed="rId3"/>
+          <a:stretch>
+            <a:fillRect/>
+          </a:stretch>
+        </p:blipFill>
+        <p:spPr>
+          <a:xfrm>
+            <a:off x="393028" y="0"/>
+            <a:ext cx="5597283" cy="6858000"/>
+          </a:xfrm>
+          <a:prstGeom prst="rect">
+            <a:avLst/>
+          </a:prstGeom>
+        </p:spPr>
+      </p:pic>
+      <p:pic>
+        <p:nvPicPr>
+          <p:cNvPr id="5" name="Рисунок 4" descr="Изображение выглядит как снимок экрана, текст, Симметрия&#10;&#10;Контент, сгенерированный ИИ, может содержать ошибки.">
+            <a:extLst>
+              <a:ext uri="{FF2B5EF4-FFF2-40B4-BE49-F238E27FC236}">
+                <a16:creationId xmlns:a16="http://schemas.microsoft.com/office/drawing/2014/main" id="{639F4AAA-D24A-D68D-267E-ADECF5EAB14F}"/>
+              </a:ext>
+            </a:extLst>
+          </p:cNvPr>
+          <p:cNvPicPr>
+            <a:picLocks noChangeAspect="1"/>
+          </p:cNvPicPr>
+          <p:nvPr/>
+        </p:nvPicPr>
+        <p:blipFill>
+          <a:blip r:embed="rId4"/>
+          <a:stretch>
+            <a:fillRect/>
+          </a:stretch>
+        </p:blipFill>
+        <p:spPr>
+          <a:xfrm>
+            <a:off x="6188467" y="760287"/>
+            <a:ext cx="5610505" cy="6097713"/>
+          </a:xfrm>
+          <a:prstGeom prst="rect">
+            <a:avLst/>
+          </a:prstGeom>
+        </p:spPr>
+      </p:pic>
+    </p:spTree>
+    <p:extLst>
+      <p:ext uri="{BB962C8B-B14F-4D97-AF65-F5344CB8AC3E}">
+        <p14:creationId xmlns:p14="http://schemas.microsoft.com/office/powerpoint/2010/main" val="2318431550"/>
+      </p:ext>
+    </p:extLst>
+  </p:cSld>
+  <p:clrMapOvr>
+    <a:masterClrMapping/>
+  </p:clrMapOvr>
+</p:sld>
+</file>
+
+<file path=ppt/slides/slide33.xml><?xml version="1.0" encoding="utf-8"?>
+<p:sld xmlns:a="http://schemas.openxmlformats.org/drawingml/2006/main" xmlns:r="http://schemas.openxmlformats.org/officeDocument/2006/relationships" xmlns:p="http://schemas.openxmlformats.org/presentationml/2006/main">
+  <p:cSld>
+    <p:spTree>
+      <p:nvGrpSpPr>
+        <p:cNvPr id="1" name=""/>
+        <p:cNvGrpSpPr/>
+        <p:nvPr/>
+      </p:nvGrpSpPr>
+      <p:grpSpPr>
+        <a:xfrm>
+          <a:off x="0" y="0"/>
+          <a:ext cx="0" cy="0"/>
+          <a:chOff x="0" y="0"/>
+          <a:chExt cx="0" cy="0"/>
+        </a:xfrm>
+      </p:grpSpPr>
+      <p:pic>
+        <p:nvPicPr>
+          <p:cNvPr id="3" name="Рисунок 2" descr="Изображение выглядит как текст, снимок экрана, программное обеспечение, Мультимедийное программное обеспечение">
+            <a:extLst>
+              <a:ext uri="{FF2B5EF4-FFF2-40B4-BE49-F238E27FC236}">
+                <a16:creationId xmlns:a16="http://schemas.microsoft.com/office/drawing/2014/main" id="{14BF01F4-91B2-9E90-2A33-E285E5EAC06F}"/>
+              </a:ext>
+            </a:extLst>
+          </p:cNvPr>
+          <p:cNvPicPr>
+            <a:picLocks noChangeAspect="1"/>
+          </p:cNvPicPr>
+          <p:nvPr/>
+        </p:nvPicPr>
+        <p:blipFill>
+          <a:blip r:embed="rId3"/>
+          <a:stretch>
+            <a:fillRect/>
+          </a:stretch>
+        </p:blipFill>
+        <p:spPr>
+          <a:xfrm>
+            <a:off x="1147239" y="341471"/>
+            <a:ext cx="4861674" cy="2989899"/>
+          </a:xfrm>
+          <a:prstGeom prst="rect">
+            <a:avLst/>
+          </a:prstGeom>
+        </p:spPr>
+      </p:pic>
+      <p:pic>
+        <p:nvPicPr>
+          <p:cNvPr id="5" name="Рисунок 4" descr="Изображение выглядит как текст, снимок экрана, программное обеспечение, Мультимедийное программное обеспечение">
+            <a:extLst>
+              <a:ext uri="{FF2B5EF4-FFF2-40B4-BE49-F238E27FC236}">
+                <a16:creationId xmlns:a16="http://schemas.microsoft.com/office/drawing/2014/main" id="{F38C3EE6-139D-D5A6-3E06-E8FBAFD99672}"/>
+              </a:ext>
+            </a:extLst>
+          </p:cNvPr>
+          <p:cNvPicPr>
+            <a:picLocks noChangeAspect="1"/>
+          </p:cNvPicPr>
+          <p:nvPr/>
+        </p:nvPicPr>
+        <p:blipFill>
+          <a:blip r:embed="rId4"/>
+          <a:stretch>
+            <a:fillRect/>
+          </a:stretch>
+        </p:blipFill>
+        <p:spPr>
+          <a:xfrm>
+            <a:off x="6183088" y="146210"/>
+            <a:ext cx="5897211" cy="3185160"/>
+          </a:xfrm>
+          <a:prstGeom prst="rect">
+            <a:avLst/>
+          </a:prstGeom>
+        </p:spPr>
+      </p:pic>
+      <p:pic>
+        <p:nvPicPr>
+          <p:cNvPr id="7" name="Рисунок 6" descr="Изображение выглядит как снимок экрана, текст, программное обеспечение, Мультимедийное программное обеспечение">
+            <a:extLst>
+              <a:ext uri="{FF2B5EF4-FFF2-40B4-BE49-F238E27FC236}">
+                <a16:creationId xmlns:a16="http://schemas.microsoft.com/office/drawing/2014/main" id="{A325BA4E-4F79-AEB1-0757-921588A5C367}"/>
+              </a:ext>
+            </a:extLst>
+          </p:cNvPr>
+          <p:cNvPicPr>
+            <a:picLocks noChangeAspect="1"/>
+          </p:cNvPicPr>
+          <p:nvPr/>
+        </p:nvPicPr>
+        <p:blipFill>
+          <a:blip r:embed="rId5"/>
+          <a:stretch>
+            <a:fillRect/>
+          </a:stretch>
+        </p:blipFill>
+        <p:spPr>
+          <a:xfrm>
+            <a:off x="2337662" y="3526631"/>
+            <a:ext cx="7516676" cy="3198437"/>
+          </a:xfrm>
+          <a:prstGeom prst="rect">
+            <a:avLst/>
+          </a:prstGeom>
+        </p:spPr>
+      </p:pic>
+    </p:spTree>
+    <p:extLst>
+      <p:ext uri="{BB962C8B-B14F-4D97-AF65-F5344CB8AC3E}">
+        <p14:creationId xmlns:p14="http://schemas.microsoft.com/office/powerpoint/2010/main" val="395047054"/>
+      </p:ext>
+    </p:extLst>
+  </p:cSld>
+  <p:clrMapOvr>
+    <a:masterClrMapping/>
+  </p:clrMapOvr>
+</p:sld>
+</file>
+
+<file path=ppt/slides/slide34.xml><?xml version="1.0" encoding="utf-8"?>
+<p:sld xmlns:a="http://schemas.openxmlformats.org/drawingml/2006/main" xmlns:r="http://schemas.openxmlformats.org/officeDocument/2006/relationships" xmlns:p="http://schemas.openxmlformats.org/presentationml/2006/main">
+  <p:cSld>
+    <p:spTree>
+      <p:nvGrpSpPr>
+        <p:cNvPr id="1" name=""/>
+        <p:cNvGrpSpPr/>
+        <p:nvPr/>
+      </p:nvGrpSpPr>
+      <p:grpSpPr>
+        <a:xfrm>
+          <a:off x="0" y="0"/>
+          <a:ext cx="0" cy="0"/>
+          <a:chOff x="0" y="0"/>
+          <a:chExt cx="0" cy="0"/>
+        </a:xfrm>
+      </p:grpSpPr>
       <p:sp>
         <p:nvSpPr>
           <p:cNvPr id="3" name="TextBox 2">
@@ -45657,7 +46182,7 @@
     </p:spTree>
     <p:extLst>
       <p:ext uri="{BB962C8B-B14F-4D97-AF65-F5344CB8AC3E}">
-        <p14:creationId xmlns:p14="http://schemas.microsoft.com/office/powerpoint/2010/main" val="2318431550"/>
+        <p14:creationId xmlns:p14="http://schemas.microsoft.com/office/powerpoint/2010/main" val="2899089893"/>
       </p:ext>
     </p:extLst>
   </p:cSld>

</xml_diff>